<commit_message>
Deck reframed around APP scams, PDF added, Scam Shield evaluated
- Deck: FirstStep as the last checkpoint before the money leaves. Regulation
  first (UK APP reimbursement, Singapore SRF, CBSL 'Be Scam Proof'), payment
  checkpoint as feature #1, flow starts at the transfer, a direct answer to
  'why not Google Messages or ScamShield', Scam Shield evaluation leads the
  benchmark slide. The two checks are described as side by side, not linked.
  PDF export for the submission portal.
- eval/scam_synthetic_v1.jsonl: 40 labelled English messages. Rules only
  9/20 recall; Gemini + rules on the live service 20/20, precision 1.00,
  0 false positives. Limits stated in the README and the deck.
- Demo script caption filled with the evaluation result.
</commit_message>
<xml_diff>
--- a/docs/deck/FirstStep_AI_Builder_Cup_2026.pptx
+++ b/docs/deck/FirstStep_AI_Builder_Cup_2026.pptx
@@ -304,7 +304,7 @@
               <a:rPr sz="1000" b="1">
                 <a:latin typeface="Arial"/>
               </a:rPr>
-              <a:t>Forecast pinball loss, 7 matched folds (lower is better)</a:t>
+              <a:t>Scam Shield: scams caught, 40 labelled messages</a:t>
             </a:r>
           </a:p>
         </c:rich>
@@ -326,7 +326,7 @@
               <c:strCache>
                 <c:ptCount val="1"/>
                 <c:pt idx="0">
-                  <c:v>Pinball loss</c:v>
+                  <c:v>Scams caught (recall)</c:v>
                 </c:pt>
               </c:strCache>
             </c:strRef>
@@ -353,10 +353,10 @@
               <c:strCache>
                 <c:ptCount val="2"/>
                 <c:pt idx="0">
-                  <c:v>LSTM baseline</c:v>
+                  <c:v>Rules only</c:v>
                 </c:pt>
                 <c:pt idx="1">
-                  <c:v>Hybrid (TimesFM + LoRA)</c:v>
+                  <c:v>Gemini + rules (live)</c:v>
                 </c:pt>
               </c:strCache>
             </c:strRef>
@@ -368,17 +368,17 @@
                 <c:formatCode>General</c:formatCode>
                 <c:ptCount val="2"/>
                 <c:pt idx="0">
-                  <c:v>0.00858</c:v>
+                  <c:v>0.45</c:v>
                 </c:pt>
                 <c:pt idx="1">
-                  <c:v>0.008</c:v>
+                  <c:v>1.0</c:v>
                 </c:pt>
               </c:numCache>
             </c:numRef>
           </c:val>
         </c:ser>
         <c:dLbls>
-          <c:numFmt formatCode="0.00000" sourceLinked="0"/>
+          <c:numFmt formatCode="0%" sourceLinked="0"/>
           <c:txPr>
             <a:bodyPr/>
             <a:lstStyle/>
@@ -434,7 +434,7 @@
       <c:valAx>
         <c:axId val="-2113994440"/>
         <c:scaling>
-          <c:max val="0.0108"/>
+          <c:max val="1.25"/>
           <c:min val="0.0"/>
         </c:scaling>
         <c:delete/>
@@ -1649,7 +1649,7 @@
           <a:lstStyle/>
           <a:p>
             <a:r>
-              <a:t>Kamala, a retired teacher, is the user we design for. The four steps are the demo video.</a:t>
+              <a:t>Sources: UK PSR APP reimbursement (7 Oct 2024); Singapore MAS/IMDA Shared Responsibility Framework (16 Dec 2024); Newsfirst 2 Jun 2026 (CBSL 'Be Scam Proof'); UNODC 2025; GASA 2025.</a:t>
             </a:r>
           </a:p>
         </p:txBody>
@@ -7094,7 +7094,7 @@
                 </a:solidFill>
                 <a:latin typeface="Arial"/>
               </a:rPr>
-              <a:t>Challenge 1 (BFSI): Intelligent Risk, Fraud &amp; Financial Experiences</a:t>
+              <a:t>Challenge 1 (BFSI) · Stopping the payment a scam victim approves (APP fraud)</a:t>
             </a:r>
             <a:endParaRPr sz="1800">
               <a:latin typeface="Google Sans Flex"/>
@@ -7800,7 +7800,7 @@
         </p:nvGraphicFramePr>
         <p:xfrm>
           <a:off x="274320" y="1188720"/>
-          <a:ext cx="4206240" cy="2103120"/>
+          <a:ext cx="4206240" cy="1920240"/>
         </p:xfrm>
         <a:graphic>
           <a:graphicData uri="http://schemas.openxmlformats.org/drawingml/2006/chart">
@@ -7816,8 +7816,8 @@
         </p:nvSpPr>
         <p:spPr>
           <a:xfrm>
-            <a:off x="274320" y="3383280"/>
-            <a:ext cx="4206240" cy="1463040"/>
+            <a:off x="274320" y="3200400"/>
+            <a:ext cx="4206240" cy="1691640"/>
           </a:xfrm>
           <a:prstGeom prst="rect">
             <a:avLst/>
@@ -7836,13 +7836,13 @@
               </a:spcAft>
             </a:pPr>
             <a:r>
-              <a:rPr sz="1800" b="1" i="0">
+              <a:rPr sz="1500" b="1" i="0">
                 <a:solidFill>
                   <a:srgbClr val="0B6E4F"/>
                 </a:solidFill>
                 <a:latin typeface="Arial"/>
               </a:rPr>
-              <a:t>−6.8% pinball loss</a:t>
+              <a:t>20 / 20 scams flagged, 0 false alarms</a:t>
             </a:r>
           </a:p>
           <a:p>
@@ -7852,13 +7852,29 @@
               </a:spcAft>
             </a:pPr>
             <a:r>
-              <a:rPr sz="1000" b="0" i="0">
+              <a:rPr sz="950" b="0" i="0">
                 <a:solidFill>
                   <a:srgbClr val="55625F"/>
                 </a:solidFill>
                 <a:latin typeface="Arial"/>
               </a:rPr>
-              <a:t>MAE 0.0248 vs 0.0264. Upper band more honest (p90 coverage 87.2% vs 84.4%, target 90%). Not better everywhere: p10 and p50 coverage drift further from target. Walk-forward, no look-ahead, 8,558 vs 9,944 predictions.</a:t>
+              <a:t>Gemini reading red flags lifts recall from 45% to 100% at the same zero false-positive rate (precision 1.00). Honest limits: 40 synthetic English messages written by the team (eval/scam_synthetic_v1.jsonl); Sinhala and Tamil not yet measured; a real labelled Sri Lankan set is next.</a:t>
+            </a:r>
+          </a:p>
+          <a:p>
+            <a:pPr algn="l">
+              <a:spcAft>
+                <a:spcPts val="400"/>
+              </a:spcAft>
+            </a:pPr>
+            <a:r>
+              <a:rPr sz="950" b="0" i="0">
+                <a:solidFill>
+                  <a:srgbClr val="55625F"/>
+                </a:solidFill>
+                <a:latin typeface="Arial"/>
+              </a:rPr>
+              <a:t>Forecasting (offline): fine-tuned TimesFM hybrid, −6.8% pinball loss vs LSTM.</a:t>
             </a:r>
           </a:p>
         </p:txBody>
@@ -8874,7 +8890,7 @@
                 </a:solidFill>
                 <a:latin typeface="Arial"/>
               </a:rPr>
-              <a:t>Serve TimesFM</a:t>
+              <a:t>Link the checks</a:t>
             </a:r>
           </a:p>
         </p:txBody>
@@ -8909,7 +8925,7 @@
                 </a:solidFill>
                 <a:latin typeface="Arial"/>
               </a:rPr>
-              <a:t>Bring the fine-tuned hybrid online behind the planner.</a:t>
+              <a:t>Feed the message verdict into the transfer decision.</a:t>
             </a:r>
           </a:p>
         </p:txBody>
@@ -8988,7 +9004,7 @@
                 </a:solidFill>
                 <a:latin typeface="Arial"/>
               </a:rPr>
-              <a:t>Gemini on Vertex AI + ADK</a:t>
+              <a:t>Real-world eval</a:t>
             </a:r>
           </a:p>
         </p:txBody>
@@ -9023,7 +9039,7 @@
                 </a:solidFill>
                 <a:latin typeface="Arial"/>
               </a:rPr>
-              <a:t>Move the agent to Agent Engine; Document AI for statements.</a:t>
+              <a:t>Labelled Sri Lankan messages, Sinhala and Tamil, with partner banks.</a:t>
             </a:r>
           </a:p>
         </p:txBody>
@@ -9102,7 +9118,7 @@
                 </a:solidFill>
                 <a:latin typeface="Arial"/>
               </a:rPr>
-              <a:t>Public chain</a:t>
+              <a:t>Gemini on Vertex AI + ADK</a:t>
             </a:r>
           </a:p>
         </p:txBody>
@@ -9137,7 +9153,7 @@
                 </a:solidFill>
                 <a:latin typeface="Arial"/>
               </a:rPr>
-              <a:t>Anchor on an Ethereum testnet via Blockchain Node Engine.</a:t>
+              <a:t>Move the agent to Agent Engine; Document AI for statements.</a:t>
             </a:r>
           </a:p>
         </p:txBody>
@@ -9216,7 +9232,7 @@
                 </a:solidFill>
                 <a:latin typeface="Arial"/>
               </a:rPr>
-              <a:t>WhatsApp bot</a:t>
+              <a:t>Public anchoring</a:t>
             </a:r>
           </a:p>
         </p:txBody>
@@ -9251,7 +9267,7 @@
                 </a:solidFill>
                 <a:latin typeface="Arial"/>
               </a:rPr>
-              <a:t>Forward a message, get the verdict back in the same chat.</a:t>
+              <a:t>Anchor the log on a public testnet via Blockchain Node Engine.</a:t>
             </a:r>
           </a:p>
         </p:txBody>
@@ -9330,7 +9346,7 @@
                 </a:solidFill>
                 <a:latin typeface="Arial"/>
               </a:rPr>
-              <a:t>Fine-tuned Laya</a:t>
+              <a:t>WhatsApp bot</a:t>
             </a:r>
           </a:p>
         </p:txBody>
@@ -9365,7 +9381,7 @@
                 </a:solidFill>
                 <a:latin typeface="Arial"/>
               </a:rPr>
-              <a:t>Fast on-device checks distilled from Gemini, validated per language.</a:t>
+              <a:t>Forward a message, get the verdict back in the same chat.</a:t>
             </a:r>
           </a:p>
         </p:txBody>
@@ -11425,7 +11441,7 @@
         </p:nvSpPr>
         <p:spPr>
           <a:xfrm>
-            <a:off x="274320" y="1143000"/>
+            <a:off x="274320" y="1115568"/>
             <a:ext cx="8595360" cy="566928"/>
           </a:xfrm>
           <a:prstGeom prst="rect">
@@ -11441,27 +11457,71 @@
           <a:p>
             <a:pPr algn="l"/>
             <a:r>
+              <a:rPr sz="1300" b="1" i="0">
+                <a:solidFill>
+                  <a:srgbClr val="0B6E4F"/>
+                </a:solidFill>
+                <a:latin typeface="Arial"/>
+              </a:rPr>
+              <a:t>FirstStep is the last checkpoint before the money leaves. </a:t>
+            </a:r>
+            <a:r>
               <a:rPr sz="1300" b="0" i="0">
                 <a:solidFill>
                   <a:srgbClr val="14201F"/>
                 </a:solidFill>
                 <a:latin typeface="Arial"/>
               </a:rPr>
-              <a:t>FirstStep checks a scam before the money moves, explains every decision in Sinhala, Tamil or English, plans cash withdrawals at the lowest loss, and seals every decision so nobody can quietly change it later.</a:t>
-            </a:r>
-          </a:p>
-        </p:txBody>
-      </p:sp>
-      <p:sp>
-        <p:nvSpPr>
-          <p:cNvPr id="73" name="Rounded Rectangle 72"/>
+              <a:t>It catches the scam at the moment of payment, explains it to the customer in Sinhala, Tamil or English, and gives the bank and regulator a record that can't be quietly changed.</a:t>
+            </a:r>
+          </a:p>
+        </p:txBody>
+      </p:sp>
+      <p:sp>
+        <p:nvSpPr>
+          <p:cNvPr id="73" name="TextBox 72"/>
+          <p:cNvSpPr txBox="1"/>
+          <p:nvPr/>
+        </p:nvSpPr>
+        <p:spPr>
+          <a:xfrm>
+            <a:off x="274320" y="1847088"/>
+            <a:ext cx="8595360" cy="411480"/>
+          </a:xfrm>
+          <a:prstGeom prst="rect">
+            <a:avLst/>
+          </a:prstGeom>
+          <a:noFill/>
+        </p:spPr>
+        <p:txBody>
+          <a:bodyPr wrap="square" anchor="t" lIns="0" rIns="0" tIns="0" bIns="0">
+            <a:spAutoFit/>
+          </a:bodyPr>
+          <a:lstStyle/>
+          <a:p>
+            <a:pPr algn="l"/>
+            <a:r>
+              <a:rPr sz="1050" b="0" i="0">
+                <a:solidFill>
+                  <a:srgbClr val="55625F"/>
+                </a:solidFill>
+                <a:latin typeface="Arial"/>
+              </a:rPr>
+              <a:t>In an authorised push payment scam the customer passes every check herself: right login, right OTP, her own decision to pay. Regulators are moving that loss onto banks.</a:t>
+            </a:r>
+          </a:p>
+        </p:txBody>
+      </p:sp>
+      <p:sp>
+        <p:nvSpPr>
+          <p:cNvPr id="74" name="Rounded Rectangle 73"/>
           <p:cNvSpPr/>
           <p:nvPr/>
         </p:nvSpPr>
         <p:spPr>
           <a:xfrm>
-            <a:off x="274320" y="1874519"/>
-            <a:ext cx="2743200" cy="1097280"/>
+            <a:off x="274320" y="2304288"/>
+            <a:ext cx="2743200" cy="914400"/>
           </a:xfrm>
           <a:prstGeom prst="roundRect">
             <a:avLst>
@@ -11498,14 +11558,14 @@
       </p:sp>
       <p:sp>
         <p:nvSpPr>
-          <p:cNvPr id="74" name="TextBox 73"/>
-          <p:cNvSpPr txBox="1"/>
-          <p:nvPr/>
-        </p:nvSpPr>
-        <p:spPr>
-          <a:xfrm>
-            <a:off x="411479" y="1947672"/>
-            <a:ext cx="2468880" cy="457200"/>
+          <p:cNvPr id="75" name="TextBox 74"/>
+          <p:cNvSpPr txBox="1"/>
+          <p:nvPr/>
+        </p:nvSpPr>
+        <p:spPr>
+          <a:xfrm>
+            <a:off x="411479" y="2359152"/>
+            <a:ext cx="2468880" cy="365760"/>
           </a:xfrm>
           <a:prstGeom prst="rect">
             <a:avLst/>
@@ -11520,27 +11580,27 @@
           <a:p>
             <a:pPr algn="l"/>
             <a:r>
-              <a:rPr sz="2400" b="1" i="0">
+              <a:rPr sz="2000" b="1" i="0">
                 <a:solidFill>
                   <a:srgbClr val="0B6E4F"/>
                 </a:solidFill>
                 <a:latin typeface="Arial"/>
               </a:rPr>
-              <a:t>USD 88–114 bn</a:t>
-            </a:r>
-          </a:p>
-        </p:txBody>
-      </p:sp>
-      <p:sp>
-        <p:nvSpPr>
-          <p:cNvPr id="75" name="TextBox 74"/>
-          <p:cNvSpPr txBox="1"/>
-          <p:nvPr/>
-        </p:nvSpPr>
-        <p:spPr>
-          <a:xfrm>
-            <a:off x="411479" y="2423160"/>
-            <a:ext cx="2468880" cy="502920"/>
+              <a:t>Oct 2024</a:t>
+            </a:r>
+          </a:p>
+        </p:txBody>
+      </p:sp>
+      <p:sp>
+        <p:nvSpPr>
+          <p:cNvPr id="76" name="TextBox 75"/>
+          <p:cNvSpPr txBox="1"/>
+          <p:nvPr/>
+        </p:nvSpPr>
+        <p:spPr>
+          <a:xfrm>
+            <a:off x="411479" y="2724912"/>
+            <a:ext cx="2468880" cy="457200"/>
           </a:xfrm>
           <a:prstGeom prst="rect">
             <a:avLst/>
@@ -11555,27 +11615,27 @@
           <a:p>
             <a:pPr algn="l"/>
             <a:r>
-              <a:rPr sz="1050" b="0" i="0">
+              <a:rPr sz="1000" b="0" i="0">
                 <a:solidFill>
                   <a:srgbClr val="55625F"/>
                 </a:solidFill>
                 <a:latin typeface="Arial"/>
               </a:rPr>
-              <a:t>lost to transnational online scams across Asia-Pacific in 2025 (UNODC)</a:t>
-            </a:r>
-          </a:p>
-        </p:txBody>
-      </p:sp>
-      <p:sp>
-        <p:nvSpPr>
-          <p:cNvPr id="76" name="Rounded Rectangle 75"/>
+              <a:t>UK: mandatory reimbursement of APP scam losses, up to GBP 85,000 per claim</a:t>
+            </a:r>
+          </a:p>
+        </p:txBody>
+      </p:sp>
+      <p:sp>
+        <p:nvSpPr>
+          <p:cNvPr id="77" name="Rounded Rectangle 76"/>
           <p:cNvSpPr/>
           <p:nvPr/>
         </p:nvSpPr>
         <p:spPr>
           <a:xfrm>
-            <a:off x="3163824" y="1874519"/>
-            <a:ext cx="2743200" cy="1097280"/>
+            <a:off x="3163824" y="2304288"/>
+            <a:ext cx="2743200" cy="914400"/>
           </a:xfrm>
           <a:prstGeom prst="roundRect">
             <a:avLst>
@@ -11612,14 +11672,14 @@
       </p:sp>
       <p:sp>
         <p:nvSpPr>
-          <p:cNvPr id="77" name="TextBox 76"/>
-          <p:cNvSpPr txBox="1"/>
-          <p:nvPr/>
-        </p:nvSpPr>
-        <p:spPr>
-          <a:xfrm>
-            <a:off x="3300984" y="1947672"/>
-            <a:ext cx="2468880" cy="457200"/>
+          <p:cNvPr id="78" name="TextBox 77"/>
+          <p:cNvSpPr txBox="1"/>
+          <p:nvPr/>
+        </p:nvSpPr>
+        <p:spPr>
+          <a:xfrm>
+            <a:off x="3300984" y="2359152"/>
+            <a:ext cx="2468880" cy="365760"/>
           </a:xfrm>
           <a:prstGeom prst="rect">
             <a:avLst/>
@@ -11634,27 +11694,27 @@
           <a:p>
             <a:pPr algn="l"/>
             <a:r>
-              <a:rPr sz="2400" b="1" i="0">
+              <a:rPr sz="2000" b="1" i="0">
                 <a:solidFill>
                   <a:srgbClr val="0B6E4F"/>
                 </a:solidFill>
                 <a:latin typeface="Arial"/>
               </a:rPr>
-              <a:t>22%</a:t>
-            </a:r>
-          </a:p>
-        </p:txBody>
-      </p:sp>
-      <p:sp>
-        <p:nvSpPr>
-          <p:cNvPr id="78" name="TextBox 77"/>
-          <p:cNvSpPr txBox="1"/>
-          <p:nvPr/>
-        </p:nvSpPr>
-        <p:spPr>
-          <a:xfrm>
-            <a:off x="3300984" y="2423160"/>
-            <a:ext cx="2468880" cy="502920"/>
+              <a:t>Dec 2024</a:t>
+            </a:r>
+          </a:p>
+        </p:txBody>
+      </p:sp>
+      <p:sp>
+        <p:nvSpPr>
+          <p:cNvPr id="79" name="TextBox 78"/>
+          <p:cNvSpPr txBox="1"/>
+          <p:nvPr/>
+        </p:nvSpPr>
+        <p:spPr>
+          <a:xfrm>
+            <a:off x="3300984" y="2724912"/>
+            <a:ext cx="2468880" cy="457200"/>
           </a:xfrm>
           <a:prstGeom prst="rect">
             <a:avLst/>
@@ -11669,27 +11729,27 @@
           <a:p>
             <a:pPr algn="l"/>
             <a:r>
-              <a:rPr sz="1050" b="0" i="0">
+              <a:rPr sz="1000" b="0" i="0">
                 <a:solidFill>
                   <a:srgbClr val="55625F"/>
                 </a:solidFill>
                 <a:latin typeface="Arial"/>
               </a:rPr>
-              <a:t>of Southeast Asian scam victims recovered any money (GASA 2025)</a:t>
-            </a:r>
-          </a:p>
-        </p:txBody>
-      </p:sp>
-      <p:sp>
-        <p:nvSpPr>
-          <p:cNvPr id="79" name="Rounded Rectangle 78"/>
+              <a:t>Singapore: Shared Responsibility Framework puts duties on banks and telcos</a:t>
+            </a:r>
+          </a:p>
+        </p:txBody>
+      </p:sp>
+      <p:sp>
+        <p:nvSpPr>
+          <p:cNvPr id="80" name="Rounded Rectangle 79"/>
           <p:cNvSpPr/>
           <p:nvPr/>
         </p:nvSpPr>
         <p:spPr>
           <a:xfrm>
-            <a:off x="6053328" y="1874519"/>
-            <a:ext cx="2743200" cy="1097280"/>
+            <a:off x="6053328" y="2304288"/>
+            <a:ext cx="2743200" cy="914400"/>
           </a:xfrm>
           <a:prstGeom prst="roundRect">
             <a:avLst>
@@ -11726,14 +11786,14 @@
       </p:sp>
       <p:sp>
         <p:nvSpPr>
-          <p:cNvPr id="80" name="TextBox 79"/>
-          <p:cNvSpPr txBox="1"/>
-          <p:nvPr/>
-        </p:nvSpPr>
-        <p:spPr>
-          <a:xfrm>
-            <a:off x="6190488" y="1947672"/>
-            <a:ext cx="2468880" cy="457200"/>
+          <p:cNvPr id="81" name="TextBox 80"/>
+          <p:cNvSpPr txBox="1"/>
+          <p:nvPr/>
+        </p:nvSpPr>
+        <p:spPr>
+          <a:xfrm>
+            <a:off x="6190488" y="2359152"/>
+            <a:ext cx="2468880" cy="365760"/>
           </a:xfrm>
           <a:prstGeom prst="rect">
             <a:avLst/>
@@ -11748,27 +11808,27 @@
           <a:p>
             <a:pPr algn="l"/>
             <a:r>
-              <a:rPr sz="2400" b="1" i="0">
+              <a:rPr sz="2000" b="1" i="0">
                 <a:solidFill>
                   <a:srgbClr val="0B6E4F"/>
                 </a:solidFill>
                 <a:latin typeface="Arial"/>
               </a:rPr>
-              <a:t>2×</a:t>
-            </a:r>
-          </a:p>
-        </p:txBody>
-      </p:sp>
-      <p:sp>
-        <p:nvSpPr>
-          <p:cNvPr id="81" name="TextBox 80"/>
-          <p:cNvSpPr txBox="1"/>
-          <p:nvPr/>
-        </p:nvSpPr>
-        <p:spPr>
-          <a:xfrm>
-            <a:off x="6190488" y="2423160"/>
-            <a:ext cx="2468880" cy="502920"/>
+              <a:t>Jun 2026</a:t>
+            </a:r>
+          </a:p>
+        </p:txBody>
+      </p:sp>
+      <p:sp>
+        <p:nvSpPr>
+          <p:cNvPr id="82" name="TextBox 81"/>
+          <p:cNvSpPr txBox="1"/>
+          <p:nvPr/>
+        </p:nvSpPr>
+        <p:spPr>
+          <a:xfrm>
+            <a:off x="6190488" y="2724912"/>
+            <a:ext cx="2468880" cy="457200"/>
           </a:xfrm>
           <a:prstGeom prst="rect">
             <a:avLst/>
@@ -11783,27 +11843,27 @@
           <a:p>
             <a:pPr algn="l"/>
             <a:r>
-              <a:rPr sz="1050" b="0" i="0">
+              <a:rPr sz="1000" b="0" i="0">
                 <a:solidFill>
                   <a:srgbClr val="55625F"/>
                 </a:solidFill>
                 <a:latin typeface="Arial"/>
               </a:rPr>
-              <a:t>online scam complaints to Sri Lanka Police in one year, to about 3,100</a:t>
-            </a:r>
-          </a:p>
-        </p:txBody>
-      </p:sp>
-      <p:sp>
-        <p:nvSpPr>
-          <p:cNvPr id="82" name="Rounded Rectangle 81"/>
+              <a:t>Sri Lanka: CBSL makes “Be Scam Proof” its consumer-protection theme</a:t>
+            </a:r>
+          </a:p>
+        </p:txBody>
+      </p:sp>
+      <p:sp>
+        <p:nvSpPr>
+          <p:cNvPr id="83" name="Rounded Rectangle 82"/>
           <p:cNvSpPr/>
           <p:nvPr/>
         </p:nvSpPr>
         <p:spPr>
           <a:xfrm>
-            <a:off x="274320" y="3154680"/>
-            <a:ext cx="2011680" cy="1325880"/>
+            <a:off x="274320" y="3383280"/>
+            <a:ext cx="2011680" cy="1280160"/>
           </a:xfrm>
           <a:prstGeom prst="roundRect">
             <a:avLst>
@@ -11840,13 +11900,13 @@
       </p:sp>
       <p:sp>
         <p:nvSpPr>
-          <p:cNvPr id="83" name="Oval 82"/>
+          <p:cNvPr id="84" name="Oval 83"/>
           <p:cNvSpPr/>
           <p:nvPr/>
         </p:nvSpPr>
         <p:spPr>
           <a:xfrm>
-            <a:off x="402336" y="3282696"/>
+            <a:off x="402336" y="3511296"/>
             <a:ext cx="310896" cy="310896"/>
           </a:xfrm>
           <a:prstGeom prst="ellipse">
@@ -11882,13 +11942,13 @@
       </p:sp>
       <p:sp>
         <p:nvSpPr>
-          <p:cNvPr id="84" name="TextBox 83"/>
-          <p:cNvSpPr txBox="1"/>
-          <p:nvPr/>
-        </p:nvSpPr>
-        <p:spPr>
-          <a:xfrm>
-            <a:off x="402336" y="3282696"/>
+          <p:cNvPr id="85" name="TextBox 84"/>
+          <p:cNvSpPr txBox="1"/>
+          <p:nvPr/>
+        </p:nvSpPr>
+        <p:spPr>
+          <a:xfrm>
+            <a:off x="402336" y="3511296"/>
             <a:ext cx="310896" cy="310896"/>
           </a:xfrm>
           <a:prstGeom prst="rect">
@@ -11917,13 +11977,13 @@
       </p:sp>
       <p:sp>
         <p:nvSpPr>
-          <p:cNvPr id="85" name="TextBox 84"/>
-          <p:cNvSpPr txBox="1"/>
-          <p:nvPr/>
-        </p:nvSpPr>
-        <p:spPr>
-          <a:xfrm>
-            <a:off x="804672" y="3282696"/>
+          <p:cNvPr id="86" name="TextBox 85"/>
+          <p:cNvSpPr txBox="1"/>
+          <p:nvPr/>
+        </p:nvSpPr>
+        <p:spPr>
+          <a:xfrm>
+            <a:off x="804672" y="3511296"/>
             <a:ext cx="1353312" cy="310896"/>
           </a:xfrm>
           <a:prstGeom prst="rect">
@@ -11945,21 +12005,21 @@
                 </a:solidFill>
                 <a:latin typeface="Arial"/>
               </a:rPr>
-              <a:t>Scam check</a:t>
-            </a:r>
-          </a:p>
-        </p:txBody>
-      </p:sp>
-      <p:sp>
-        <p:nvSpPr>
-          <p:cNvPr id="86" name="TextBox 85"/>
-          <p:cNvSpPr txBox="1"/>
-          <p:nvPr/>
-        </p:nvSpPr>
-        <p:spPr>
-          <a:xfrm>
-            <a:off x="402336" y="3685032"/>
-            <a:ext cx="1755648" cy="667511"/>
+              <a:t>Pay a new payee</a:t>
+            </a:r>
+          </a:p>
+        </p:txBody>
+      </p:sp>
+      <p:sp>
+        <p:nvSpPr>
+          <p:cNvPr id="87" name="TextBox 86"/>
+          <p:cNvSpPr txBox="1"/>
+          <p:nvPr/>
+        </p:nvSpPr>
+        <p:spPr>
+          <a:xfrm>
+            <a:off x="402336" y="3913632"/>
+            <a:ext cx="1755648" cy="621791"/>
           </a:xfrm>
           <a:prstGeom prst="rect">
             <a:avLst/>
@@ -11978,26 +12038,26 @@
               </a:spcAft>
             </a:pPr>
             <a:r>
-              <a:rPr sz="1100" b="0" i="0">
+              <a:rPr sz="1050" b="0" i="0">
                 <a:solidFill>
                   <a:srgbClr val="55625F"/>
                 </a:solidFill>
                 <a:latin typeface="Arial"/>
               </a:rPr>
-              <a:t>Kamala pastes a WhatsApp offer: STOP, and why</a:t>
-            </a:r>
-          </a:p>
-        </p:txBody>
-      </p:sp>
-      <p:sp>
-        <p:nvSpPr>
-          <p:cNvPr id="87" name="Chevron 86"/>
+              <a:t>Kamala starts a Rs 30,000 transfer; the gateway asks for fresh proof</a:t>
+            </a:r>
+          </a:p>
+        </p:txBody>
+      </p:sp>
+      <p:sp>
+        <p:nvSpPr>
+          <p:cNvPr id="88" name="Chevron 87"/>
           <p:cNvSpPr/>
           <p:nvPr/>
         </p:nvSpPr>
         <p:spPr>
           <a:xfrm>
-            <a:off x="2267712" y="3730752"/>
+            <a:off x="2267712" y="3931920"/>
             <a:ext cx="164592" cy="182880"/>
           </a:xfrm>
           <a:prstGeom prst="chevron">
@@ -12035,14 +12095,14 @@
       </p:sp>
       <p:sp>
         <p:nvSpPr>
-          <p:cNvPr id="88" name="Rounded Rectangle 87"/>
+          <p:cNvPr id="89" name="Rounded Rectangle 88"/>
           <p:cNvSpPr/>
           <p:nvPr/>
         </p:nvSpPr>
         <p:spPr>
           <a:xfrm>
-            <a:off x="2441448" y="3154680"/>
-            <a:ext cx="2011680" cy="1325880"/>
+            <a:off x="2441448" y="3383280"/>
+            <a:ext cx="2011680" cy="1280160"/>
           </a:xfrm>
           <a:prstGeom prst="roundRect">
             <a:avLst>
@@ -12079,13 +12139,13 @@
       </p:sp>
       <p:sp>
         <p:nvSpPr>
-          <p:cNvPr id="89" name="Oval 88"/>
+          <p:cNvPr id="90" name="Oval 89"/>
           <p:cNvSpPr/>
           <p:nvPr/>
         </p:nvSpPr>
         <p:spPr>
           <a:xfrm>
-            <a:off x="2569464" y="3282696"/>
+            <a:off x="2569464" y="3511296"/>
             <a:ext cx="310896" cy="310896"/>
           </a:xfrm>
           <a:prstGeom prst="ellipse">
@@ -12121,13 +12181,13 @@
       </p:sp>
       <p:sp>
         <p:nvSpPr>
-          <p:cNvPr id="90" name="TextBox 89"/>
-          <p:cNvSpPr txBox="1"/>
-          <p:nvPr/>
-        </p:nvSpPr>
-        <p:spPr>
-          <a:xfrm>
-            <a:off x="2569464" y="3282696"/>
+          <p:cNvPr id="91" name="TextBox 90"/>
+          <p:cNvSpPr txBox="1"/>
+          <p:nvPr/>
+        </p:nvSpPr>
+        <p:spPr>
+          <a:xfrm>
+            <a:off x="2569464" y="3511296"/>
             <a:ext cx="310896" cy="310896"/>
           </a:xfrm>
           <a:prstGeom prst="rect">
@@ -12156,13 +12216,13 @@
       </p:sp>
       <p:sp>
         <p:nvSpPr>
-          <p:cNvPr id="91" name="TextBox 90"/>
-          <p:cNvSpPr txBox="1"/>
-          <p:nvPr/>
-        </p:nvSpPr>
-        <p:spPr>
-          <a:xfrm>
-            <a:off x="2971800" y="3282696"/>
+          <p:cNvPr id="92" name="TextBox 91"/>
+          <p:cNvSpPr txBox="1"/>
+          <p:nvPr/>
+        </p:nvSpPr>
+        <p:spPr>
+          <a:xfrm>
+            <a:off x="2971800" y="3511296"/>
             <a:ext cx="1353312" cy="310896"/>
           </a:xfrm>
           <a:prstGeom prst="rect">
@@ -12184,21 +12244,21 @@
                 </a:solidFill>
                 <a:latin typeface="Arial"/>
               </a:rPr>
-              <a:t>Explained</a:t>
-            </a:r>
-          </a:p>
-        </p:txBody>
-      </p:sp>
-      <p:sp>
-        <p:nvSpPr>
-          <p:cNvPr id="92" name="TextBox 91"/>
-          <p:cNvSpPr txBox="1"/>
-          <p:nvPr/>
-        </p:nvSpPr>
-        <p:spPr>
-          <a:xfrm>
-            <a:off x="2569464" y="3685032"/>
-            <a:ext cx="1755648" cy="667511"/>
+              <a:t>Check the offer</a:t>
+            </a:r>
+          </a:p>
+        </p:txBody>
+      </p:sp>
+      <p:sp>
+        <p:nvSpPr>
+          <p:cNvPr id="93" name="TextBox 92"/>
+          <p:cNvSpPr txBox="1"/>
+          <p:nvPr/>
+        </p:nvSpPr>
+        <p:spPr>
+          <a:xfrm>
+            <a:off x="2569464" y="3913632"/>
+            <a:ext cx="1755648" cy="621791"/>
           </a:xfrm>
           <a:prstGeom prst="rect">
             <a:avLst/>
@@ -12217,26 +12277,26 @@
               </a:spcAft>
             </a:pPr>
             <a:r>
-              <a:rPr sz="1100" b="0" i="0">
+              <a:rPr sz="1050" b="0" i="0">
                 <a:solidFill>
                   <a:srgbClr val="55625F"/>
                 </a:solidFill>
                 <a:latin typeface="Arial"/>
               </a:rPr>
-              <a:t>She asks why, by voice, in Sinhala</a:t>
-            </a:r>
-          </a:p>
-        </p:txBody>
-      </p:sp>
-      <p:sp>
-        <p:nvSpPr>
-          <p:cNvPr id="93" name="Chevron 92"/>
+              <a:t>The WhatsApp message gets a STOP verdict, and why</a:t>
+            </a:r>
+          </a:p>
+        </p:txBody>
+      </p:sp>
+      <p:sp>
+        <p:nvSpPr>
+          <p:cNvPr id="94" name="Chevron 93"/>
           <p:cNvSpPr/>
           <p:nvPr/>
         </p:nvSpPr>
         <p:spPr>
           <a:xfrm>
-            <a:off x="4434840" y="3730752"/>
+            <a:off x="4434840" y="3931920"/>
             <a:ext cx="164592" cy="182880"/>
           </a:xfrm>
           <a:prstGeom prst="chevron">
@@ -12274,14 +12334,14 @@
       </p:sp>
       <p:sp>
         <p:nvSpPr>
-          <p:cNvPr id="94" name="Rounded Rectangle 93"/>
+          <p:cNvPr id="95" name="Rounded Rectangle 94"/>
           <p:cNvSpPr/>
           <p:nvPr/>
         </p:nvSpPr>
         <p:spPr>
           <a:xfrm>
-            <a:off x="4608576" y="3154680"/>
-            <a:ext cx="2011680" cy="1325880"/>
+            <a:off x="4608576" y="3383280"/>
+            <a:ext cx="2011680" cy="1280160"/>
           </a:xfrm>
           <a:prstGeom prst="roundRect">
             <a:avLst>
@@ -12318,13 +12378,13 @@
       </p:sp>
       <p:sp>
         <p:nvSpPr>
-          <p:cNvPr id="95" name="Oval 94"/>
+          <p:cNvPr id="96" name="Oval 95"/>
           <p:cNvSpPr/>
           <p:nvPr/>
         </p:nvSpPr>
         <p:spPr>
           <a:xfrm>
-            <a:off x="4736592" y="3282696"/>
+            <a:off x="4736592" y="3511296"/>
             <a:ext cx="310896" cy="310896"/>
           </a:xfrm>
           <a:prstGeom prst="ellipse">
@@ -12360,13 +12420,13 @@
       </p:sp>
       <p:sp>
         <p:nvSpPr>
-          <p:cNvPr id="96" name="TextBox 95"/>
-          <p:cNvSpPr txBox="1"/>
-          <p:nvPr/>
-        </p:nvSpPr>
-        <p:spPr>
-          <a:xfrm>
-            <a:off x="4736592" y="3282696"/>
+          <p:cNvPr id="97" name="TextBox 96"/>
+          <p:cNvSpPr txBox="1"/>
+          <p:nvPr/>
+        </p:nvSpPr>
+        <p:spPr>
+          <a:xfrm>
+            <a:off x="4736592" y="3511296"/>
             <a:ext cx="310896" cy="310896"/>
           </a:xfrm>
           <a:prstGeom prst="rect">
@@ -12395,13 +12455,13 @@
       </p:sp>
       <p:sp>
         <p:nvSpPr>
-          <p:cNvPr id="97" name="TextBox 96"/>
-          <p:cNvSpPr txBox="1"/>
-          <p:nvPr/>
-        </p:nvSpPr>
-        <p:spPr>
-          <a:xfrm>
-            <a:off x="5138928" y="3282696"/>
+          <p:cNvPr id="98" name="TextBox 97"/>
+          <p:cNvSpPr txBox="1"/>
+          <p:nvPr/>
+        </p:nvSpPr>
+        <p:spPr>
+          <a:xfrm>
+            <a:off x="5138928" y="3511296"/>
             <a:ext cx="1353312" cy="310896"/>
           </a:xfrm>
           <a:prstGeom prst="rect">
@@ -12423,21 +12483,21 @@
                 </a:solidFill>
                 <a:latin typeface="Arial"/>
               </a:rPr>
-              <a:t>Cash plan</a:t>
-            </a:r>
-          </a:p>
-        </p:txBody>
-      </p:sp>
-      <p:sp>
-        <p:nvSpPr>
-          <p:cNvPr id="98" name="TextBox 97"/>
-          <p:cNvSpPr txBox="1"/>
-          <p:nvPr/>
-        </p:nvSpPr>
-        <p:spPr>
-          <a:xfrm>
-            <a:off x="4736592" y="3685032"/>
-            <a:ext cx="1755648" cy="667511"/>
+              <a:t>Explained</a:t>
+            </a:r>
+          </a:p>
+        </p:txBody>
+      </p:sp>
+      <p:sp>
+        <p:nvSpPr>
+          <p:cNvPr id="99" name="TextBox 98"/>
+          <p:cNvSpPr txBox="1"/>
+          <p:nvPr/>
+        </p:nvSpPr>
+        <p:spPr>
+          <a:xfrm>
+            <a:off x="4736592" y="3913632"/>
+            <a:ext cx="1755648" cy="621791"/>
           </a:xfrm>
           <a:prstGeom prst="rect">
             <a:avLst/>
@@ -12456,26 +12516,26 @@
               </a:spcAft>
             </a:pPr>
             <a:r>
-              <a:rPr sz="1100" b="0" i="0">
+              <a:rPr sz="1050" b="0" i="0">
                 <a:solidFill>
                   <a:srgbClr val="55625F"/>
                 </a:solidFill>
                 <a:latin typeface="Arial"/>
               </a:rPr>
-              <a:t>Rs 300,000 for school fees, at the lowest loss</a:t>
-            </a:r>
-          </a:p>
-        </p:txBody>
-      </p:sp>
-      <p:sp>
-        <p:nvSpPr>
-          <p:cNvPr id="99" name="Chevron 98"/>
+              <a:t>In Sinhala, with every figure checked against the tools</a:t>
+            </a:r>
+          </a:p>
+        </p:txBody>
+      </p:sp>
+      <p:sp>
+        <p:nvSpPr>
+          <p:cNvPr id="100" name="Chevron 99"/>
           <p:cNvSpPr/>
           <p:nvPr/>
         </p:nvSpPr>
         <p:spPr>
           <a:xfrm>
-            <a:off x="6601968" y="3730752"/>
+            <a:off x="6601968" y="3931920"/>
             <a:ext cx="164592" cy="182880"/>
           </a:xfrm>
           <a:prstGeom prst="chevron">
@@ -12513,14 +12573,14 @@
       </p:sp>
       <p:sp>
         <p:nvSpPr>
-          <p:cNvPr id="100" name="Rounded Rectangle 99"/>
+          <p:cNvPr id="101" name="Rounded Rectangle 100"/>
           <p:cNvSpPr/>
           <p:nvPr/>
         </p:nvSpPr>
         <p:spPr>
           <a:xfrm>
-            <a:off x="6775704" y="3154680"/>
-            <a:ext cx="2011680" cy="1325880"/>
+            <a:off x="6775704" y="3383280"/>
+            <a:ext cx="2011680" cy="1280160"/>
           </a:xfrm>
           <a:prstGeom prst="roundRect">
             <a:avLst>
@@ -12557,13 +12617,13 @@
       </p:sp>
       <p:sp>
         <p:nvSpPr>
-          <p:cNvPr id="101" name="Oval 100"/>
+          <p:cNvPr id="102" name="Oval 101"/>
           <p:cNvSpPr/>
           <p:nvPr/>
         </p:nvSpPr>
         <p:spPr>
           <a:xfrm>
-            <a:off x="6903720" y="3282696"/>
+            <a:off x="6903720" y="3511296"/>
             <a:ext cx="310896" cy="310896"/>
           </a:xfrm>
           <a:prstGeom prst="ellipse">
@@ -12599,13 +12659,13 @@
       </p:sp>
       <p:sp>
         <p:nvSpPr>
-          <p:cNvPr id="102" name="TextBox 101"/>
-          <p:cNvSpPr txBox="1"/>
-          <p:nvPr/>
-        </p:nvSpPr>
-        <p:spPr>
-          <a:xfrm>
-            <a:off x="6903720" y="3282696"/>
+          <p:cNvPr id="103" name="TextBox 102"/>
+          <p:cNvSpPr txBox="1"/>
+          <p:nvPr/>
+        </p:nvSpPr>
+        <p:spPr>
+          <a:xfrm>
+            <a:off x="6903720" y="3511296"/>
             <a:ext cx="310896" cy="310896"/>
           </a:xfrm>
           <a:prstGeom prst="rect">
@@ -12634,13 +12694,13 @@
       </p:sp>
       <p:sp>
         <p:nvSpPr>
-          <p:cNvPr id="103" name="TextBox 102"/>
-          <p:cNvSpPr txBox="1"/>
-          <p:nvPr/>
-        </p:nvSpPr>
-        <p:spPr>
-          <a:xfrm>
-            <a:off x="7306056" y="3282696"/>
+          <p:cNvPr id="104" name="TextBox 103"/>
+          <p:cNvSpPr txBox="1"/>
+          <p:nvPr/>
+        </p:nvSpPr>
+        <p:spPr>
+          <a:xfrm>
+            <a:off x="7306056" y="3511296"/>
             <a:ext cx="1353312" cy="310896"/>
           </a:xfrm>
           <a:prstGeom prst="rect">
@@ -12662,21 +12722,21 @@
                 </a:solidFill>
                 <a:latin typeface="Arial"/>
               </a:rPr>
-              <a:t>Sealed</a:t>
-            </a:r>
-          </a:p>
-        </p:txBody>
-      </p:sp>
-      <p:sp>
-        <p:nvSpPr>
-          <p:cNvPr id="104" name="TextBox 103"/>
-          <p:cNvSpPr txBox="1"/>
-          <p:nvPr/>
-        </p:nvSpPr>
-        <p:spPr>
-          <a:xfrm>
-            <a:off x="6903720" y="3685032"/>
-            <a:ext cx="1755648" cy="667511"/>
+              <a:t>Sealed record</a:t>
+            </a:r>
+          </a:p>
+        </p:txBody>
+      </p:sp>
+      <p:sp>
+        <p:nvSpPr>
+          <p:cNvPr id="105" name="TextBox 104"/>
+          <p:cNvSpPr txBox="1"/>
+          <p:nvPr/>
+        </p:nvSpPr>
+        <p:spPr>
+          <a:xfrm>
+            <a:off x="6903720" y="3913632"/>
+            <a:ext cx="1755648" cy="621791"/>
           </a:xfrm>
           <a:prstGeom prst="rect">
             <a:avLst/>
@@ -12695,13 +12755,48 @@
               </a:spcAft>
             </a:pPr>
             <a:r>
-              <a:rPr sz="1100" b="0" i="0">
+              <a:rPr sz="1050" b="0" i="0">
                 <a:solidFill>
                   <a:srgbClr val="55625F"/>
                 </a:solidFill>
                 <a:latin typeface="Arial"/>
               </a:rPr>
-              <a:t>A new payee needs fresh proof; every decision is recorded</a:t>
+              <a:t>Evidence for disputes, reimbursement and the regulator</a:t>
+            </a:r>
+          </a:p>
+        </p:txBody>
+      </p:sp>
+      <p:sp>
+        <p:nvSpPr>
+          <p:cNvPr id="106" name="TextBox 105"/>
+          <p:cNvSpPr txBox="1"/>
+          <p:nvPr/>
+        </p:nvSpPr>
+        <p:spPr>
+          <a:xfrm>
+            <a:off x="274320" y="4754880"/>
+            <a:ext cx="8595360" cy="228600"/>
+          </a:xfrm>
+          <a:prstGeom prst="rect">
+            <a:avLst/>
+          </a:prstGeom>
+          <a:noFill/>
+        </p:spPr>
+        <p:txBody>
+          <a:bodyPr wrap="square" anchor="t" lIns="0" rIns="0" tIns="0" bIns="0">
+            <a:spAutoFit/>
+          </a:bodyPr>
+          <a:lstStyle/>
+          <a:p>
+            <a:pPr algn="l"/>
+            <a:r>
+              <a:rPr sz="900" b="0" i="0">
+                <a:solidFill>
+                  <a:srgbClr val="55625F"/>
+                </a:solidFill>
+                <a:latin typeface="Arial"/>
+              </a:rPr>
+              <a:t>Also: USD 88–114 bn lost to online scams across Asia-Pacific in 2025 (UNODC); only 22% of victims recover anything (GASA).</a:t>
             </a:r>
           </a:p>
         </p:txBody>
@@ -12963,7 +13058,7 @@
                 </a:solidFill>
                 <a:latin typeface="Arial"/>
               </a:rPr>
-              <a:t>How it differs</a:t>
+              <a:t>Why not existing apps?</a:t>
             </a:r>
           </a:p>
         </p:txBody>
@@ -13011,7 +13106,7 @@
                 </a:solidFill>
                 <a:latin typeface="Arial"/>
               </a:rPr>
-              <a:t>Acts before the transfer, not after the loss</a:t>
+              <a:t>Google Messages and ScamShield protect the phone and need the victim to doubt the offer; many victims never check</a:t>
             </a:r>
           </a:p>
           <a:p>
@@ -13036,7 +13131,7 @@
                 </a:solidFill>
                 <a:latin typeface="Arial"/>
               </a:rPr>
-              <a:t>The AI never has the final say: Gemini reads red flags, a versioned policy decides</a:t>
+              <a:t>FirstStep protects the payment: it acts at the transfer, on any phone, whatever the channel (WhatsApp, calls)</a:t>
             </a:r>
           </a:p>
           <a:p>
@@ -13061,32 +13156,7 @@
                 </a:solidFill>
                 <a:latin typeface="Arial"/>
               </a:rPr>
-              <a:t>No ungrounded numbers: answers with figures no tool produced are rejected</a:t>
-            </a:r>
-          </a:p>
-          <a:p>
-            <a:pPr algn="l">
-              <a:spcAft>
-                <a:spcPts val="700"/>
-              </a:spcAft>
-            </a:pPr>
-            <a:r>
-              <a:rPr sz="1150" b="1" i="0">
-                <a:solidFill>
-                  <a:srgbClr val="0B6E4F"/>
-                </a:solidFill>
-                <a:latin typeface="Arial"/>
-              </a:rPr>
-              <a:t>•  </a:t>
-            </a:r>
-            <a:r>
-              <a:rPr sz="1150" b="0" i="0">
-                <a:solidFill>
-                  <a:srgbClr val="14201F"/>
-                </a:solidFill>
-                <a:latin typeface="Arial"/>
-              </a:rPr>
-              <a:t>Every decision is sealed with its model and policy, on a smart contract</a:t>
+              <a:t>A bank-side control, so it fits Singapore's and the UK's duties on banks</a:t>
             </a:r>
           </a:p>
         </p:txBody>
@@ -13213,7 +13283,7 @@
                 </a:solidFill>
                 <a:latin typeface="Arial"/>
               </a:rPr>
-              <a:t>Plain-language verdicts with what to do next, in the user's language</a:t>
+              <a:t>Step-up on a new payee, the moment regulators single out as high risk</a:t>
             </a:r>
           </a:p>
           <a:p>
@@ -13238,7 +13308,7 @@
                 </a:solidFill>
                 <a:latin typeface="Arial"/>
               </a:rPr>
-              <a:t>Step-up proof for risky transfers, even inside a valid session</a:t>
+              <a:t>Plain-language reasons in the customer's language, where generic English warnings fail</a:t>
             </a:r>
           </a:p>
           <a:p>
@@ -13263,7 +13333,7 @@
                 </a:solidFill>
                 <a:latin typeface="Arial"/>
               </a:rPr>
-              <a:t>A cash planner that shows its saving against selling everything at once</a:t>
+              <a:t>Policy decides, Gemini reads: the bank can tell a regulator exactly why a payment was stopped</a:t>
             </a:r>
           </a:p>
           <a:p>
@@ -13288,7 +13358,7 @@
                 </a:solidFill>
                 <a:latin typeface="Arial"/>
               </a:rPr>
-              <a:t>Banks and regulators read every decision over standard OData</a:t>
+              <a:t>A sealed, verifiable record for disputes and reimbursement claims</a:t>
             </a:r>
           </a:p>
         </p:txBody>
@@ -13415,7 +13485,7 @@
                 </a:solidFill>
                 <a:latin typeface="Arial"/>
               </a:rPr>
-              <a:t>One flow: check the offer, understand it, plan the cash, prove it later</a:t>
+              <a:t>Protects the payment, not just the phone</a:t>
             </a:r>
           </a:p>
           <a:p>
@@ -13440,7 +13510,7 @@
                 </a:solidFill>
                 <a:latin typeface="Arial"/>
               </a:rPr>
-              <a:t>Scam knowledge in Google's Open Knowledge Format, with sources and trust tiers</a:t>
+              <a:t>Live and tested on Cloud Run, not a slide: 11/11 end-to-end checks</a:t>
             </a:r>
           </a:p>
           <a:p>
@@ -13465,7 +13535,7 @@
                 </a:solidFill>
                 <a:latin typeface="Arial"/>
               </a:rPr>
-              <a:t>Built for Sri Lanka first: CSE stocks, LKR, Sinhala and Tamil</a:t>
+              <a:t>Built for Sri Lanka: Sinhala, Tamil, LKR, CSE</a:t>
             </a:r>
           </a:p>
         </p:txBody>
@@ -13796,7 +13866,7 @@
                 </a:solidFill>
                 <a:latin typeface="Arial"/>
               </a:rPr>
-              <a:t>Scam Shield</a:t>
+              <a:t>Payment checkpoint</a:t>
             </a:r>
           </a:p>
         </p:txBody>
@@ -13835,7 +13905,7 @@
                 </a:solidFill>
                 <a:latin typeface="Arial"/>
               </a:rPr>
-              <a:t>Paste any WhatsApp, SMS or email offer. Gemini reads the red flags, policy SHIELD-P001 decides, and the verdict is a STOP / CHECK / CLEAR stamp with what to do next.</a:t>
+              <a:t>Every transfer is scored by the gateway; a new payee or unusual behaviour triggers a one-time-code step-up before money leaves.</a:t>
             </a:r>
           </a:p>
         </p:txBody>
@@ -13991,7 +14061,7 @@
                 </a:solidFill>
                 <a:latin typeface="Arial"/>
               </a:rPr>
-              <a:t>Explainable assistant</a:t>
+              <a:t>Scam Shield</a:t>
             </a:r>
           </a:p>
         </p:txBody>
@@ -14030,7 +14100,7 @@
                 </a:solidFill>
                 <a:latin typeface="Arial"/>
               </a:rPr>
-              <a:t>Ask why, by text or voice, in Sinhala, Tamil or English. Gemini answers with the platform's own tools; figures are checked before you see them.</a:t>
+              <a:t>Paste a WhatsApp, SMS or email offer. Gemini reads the red flags, policy SHIELD-P001 decides: a STOP / CHECK / CLEAR stamp with what to do next.</a:t>
             </a:r>
           </a:p>
         </p:txBody>
@@ -14186,7 +14256,7 @@
                 </a:solidFill>
                 <a:latin typeface="Arial"/>
               </a:rPr>
-              <a:t>Cash planner</a:t>
+              <a:t>Explained in her language</a:t>
             </a:r>
           </a:p>
         </p:txBody>
@@ -14225,7 +14295,7 @@
                 </a:solidFill>
                 <a:latin typeface="Arial"/>
               </a:rPr>
-              <a:t>Raise an amount by a deadline at the lowest loss: fuzzy rules and a genetic algorithm, costed against three naive baselines.</a:t>
+              <a:t>Ask why, by text or voice, in Sinhala, Tamil or English. Gemini answers from the platform's tools; any unchecked figure is withheld.</a:t>
             </a:r>
           </a:p>
         </p:txBody>
@@ -14381,7 +14451,7 @@
                 </a:solidFill>
                 <a:latin typeface="Arial"/>
               </a:rPr>
-              <a:t>Zero-trust transfers</a:t>
+              <a:t>Sealed evidence</a:t>
             </a:r>
           </a:p>
         </p:txBody>
@@ -14420,7 +14490,7 @@
                 </a:solidFill>
                 <a:latin typeface="Arial"/>
               </a:rPr>
-              <a:t>Every service verifies every request (RS256, per-service audiences, roles). A risky transfer triggers a one-time-code step-up.</a:t>
+              <a:t>Each decision is hashed with its model and policy and anchored in a contract; change one field and verification fails. Readable over OData.</a:t>
             </a:r>
           </a:p>
         </p:txBody>
@@ -14576,7 +14646,7 @@
                 </a:solidFill>
                 <a:latin typeface="Arial"/>
               </a:rPr>
-              <a:t>Tamper-evident audit</a:t>
+              <a:t>Scam knowledge, open</a:t>
             </a:r>
           </a:p>
         </p:txBody>
@@ -14615,7 +14685,7 @@
                 </a:solidFill>
                 <a:latin typeface="Arial"/>
               </a:rPr>
-              <a:t>Each decision is hashed with its model and policy and anchored in a smart contract. Change one field and verification fails.</a:t>
+              <a:t>Scam patterns in Google's Open Knowledge Format, with sources and trust tiers, cited in every verdict.</a:t>
             </a:r>
           </a:p>
         </p:txBody>
@@ -14771,7 +14841,7 @@
                 </a:solidFill>
                 <a:latin typeface="Arial"/>
               </a:rPr>
-              <a:t>Open by standard</a:t>
+              <a:t>Slowing down is cheap</a:t>
             </a:r>
           </a:p>
         </p:txBody>
@@ -14810,7 +14880,7 @@
                 </a:solidFill>
                 <a:latin typeface="Arial"/>
               </a:rPr>
-              <a:t>Scam patterns in Google's Open Knowledge Format; every service speaks OData v4 so banks can plug in.</a:t>
+              <a:t>Scammers sell urgency. The cash planner shows what rushing a sale costs, and the cheapest way to raise money calmly.</a:t>
             </a:r>
           </a:p>
         </p:txBody>
@@ -15064,7 +15134,7 @@
                 </a:solidFill>
                 <a:latin typeface="Arial"/>
               </a:rPr>
-              <a:t>Message</a:t>
+              <a:t>Transfer</a:t>
             </a:r>
           </a:p>
         </p:txBody>
@@ -15099,7 +15169,7 @@
                 </a:solidFill>
                 <a:latin typeface="Arial"/>
               </a:rPr>
-              <a:t>WhatsApp / SMS offer pasted in</a:t>
+              <a:t>Kamala pays Rs 30,000 to a new payee</a:t>
             </a:r>
           </a:p>
         </p:txBody>
@@ -15165,7 +15235,7 @@
             </a:avLst>
           </a:prstGeom>
           <a:solidFill>
-            <a:srgbClr val="E7F4EE"/>
+            <a:srgbClr val="F3F5F4"/>
           </a:solidFill>
           <a:ln>
             <a:noFill/>
@@ -15218,11 +15288,11 @@
             <a:r>
               <a:rPr sz="1300" b="1" i="0">
                 <a:solidFill>
-                  <a:srgbClr val="0B6E4F"/>
+                  <a:srgbClr val="14201F"/>
                 </a:solidFill>
                 <a:latin typeface="Arial"/>
               </a:rPr>
-              <a:t>Gemini</a:t>
+              <a:t>Gateway</a:t>
             </a:r>
           </a:p>
         </p:txBody>
@@ -15257,7 +15327,7 @@
                 </a:solidFill>
                 <a:latin typeface="Arial"/>
               </a:rPr>
-              <a:t>Reads red flags: guaranteed return, licence, payment route</a:t>
+              <a:t>Behavioural and network risk score</a:t>
             </a:r>
           </a:p>
         </p:txBody>
@@ -15323,7 +15393,7 @@
             </a:avLst>
           </a:prstGeom>
           <a:solidFill>
-            <a:srgbClr val="F3F5F4"/>
+            <a:srgbClr val="FDF3E1"/>
           </a:solidFill>
           <a:ln>
             <a:noFill/>
@@ -15376,11 +15446,11 @@
             <a:r>
               <a:rPr sz="1300" b="1" i="0">
                 <a:solidFill>
-                  <a:srgbClr val="14201F"/>
+                  <a:srgbClr val="8A5300"/>
                 </a:solidFill>
                 <a:latin typeface="Arial"/>
               </a:rPr>
-              <a:t>SHIELD-P001</a:t>
+              <a:t>STEP‑UP</a:t>
             </a:r>
           </a:p>
         </p:txBody>
@@ -15415,7 +15485,7 @@
                 </a:solidFill>
                 <a:latin typeface="Arial"/>
               </a:rPr>
-              <a:t>Versioned rules decide the verdict</a:t>
+              <a:t>Fresh one-time-code proof before money moves</a:t>
             </a:r>
           </a:p>
         </p:txBody>
@@ -15481,7 +15551,7 @@
             </a:avLst>
           </a:prstGeom>
           <a:solidFill>
-            <a:srgbClr val="FDECEA"/>
+            <a:srgbClr val="E7F4EE"/>
           </a:solidFill>
           <a:ln>
             <a:noFill/>
@@ -15534,11 +15604,11 @@
             <a:r>
               <a:rPr sz="1300" b="1" i="0">
                 <a:solidFill>
-                  <a:srgbClr val="B42318"/>
+                  <a:srgbClr val="0B6E4F"/>
                 </a:solidFill>
                 <a:latin typeface="Arial"/>
               </a:rPr>
-              <a:t>STOP</a:t>
+              <a:t>Check the offer</a:t>
             </a:r>
           </a:p>
         </p:txBody>
@@ -15573,7 +15643,7 @@
                 </a:solidFill>
                 <a:latin typeface="Arial"/>
               </a:rPr>
-              <a:t>What to do next, why, and the OKF scam patterns cited</a:t>
+              <a:t>Gemini reads the WhatsApp message's red flags</a:t>
             </a:r>
           </a:p>
         </p:txBody>
@@ -15639,7 +15709,7 @@
             </a:avLst>
           </a:prstGeom>
           <a:solidFill>
-            <a:srgbClr val="F3F5F4"/>
+            <a:srgbClr val="FDECEA"/>
           </a:solidFill>
           <a:ln>
             <a:noFill/>
@@ -15692,11 +15762,11 @@
             <a:r>
               <a:rPr sz="1300" b="1" i="0">
                 <a:solidFill>
-                  <a:srgbClr val="14201F"/>
+                  <a:srgbClr val="B42318"/>
                 </a:solidFill>
                 <a:latin typeface="Arial"/>
               </a:rPr>
-              <a:t>Sealed</a:t>
+              <a:t>STOP</a:t>
             </a:r>
           </a:p>
         </p:txBody>
@@ -15731,7 +15801,7 @@
                 </a:solidFill>
                 <a:latin typeface="Arial"/>
               </a:rPr>
-              <a:t>Hash + model + policy anchored in AuditRegistry</a:t>
+              <a:t>SHIELD-P001 verdict, what to do, why, scam patterns</a:t>
             </a:r>
           </a:p>
         </p:txBody>
@@ -15766,7 +15836,7 @@
                 </a:solidFill>
                 <a:latin typeface="Arial"/>
               </a:rPr>
-              <a:t>Then the money decision, with the same guarantees</a:t>
+              <a:t>Then the customer's question and the bank's record</a:t>
             </a:r>
           </a:p>
         </p:txBody>
@@ -15880,7 +15950,7 @@
                 </a:solidFill>
                 <a:latin typeface="Arial"/>
               </a:rPr>
-              <a:t>Assistant answers in Sinhala; grounding rejects invented figures</a:t>
+              <a:t>Assistant answers in Sinhala; invented figures are withheld</a:t>
             </a:r>
           </a:p>
         </p:txBody>
@@ -16003,7 +16073,7 @@
                 </a:solidFill>
                 <a:latin typeface="Arial"/>
               </a:rPr>
-              <a:t>Cash plan</a:t>
+              <a:t>Decide</a:t>
             </a:r>
           </a:p>
         </p:txBody>
@@ -16038,7 +16108,7 @@
                 </a:solidFill>
                 <a:latin typeface="Arial"/>
               </a:rPr>
-              <a:t>Rs 300,000 by a deadline: day-by-day sales, cost vs. 3 baselines</a:t>
+              <a:t>She cancels, or proves it is really her</a:t>
             </a:r>
           </a:p>
         </p:txBody>
@@ -16104,7 +16174,7 @@
             </a:avLst>
           </a:prstGeom>
           <a:solidFill>
-            <a:srgbClr val="FDF3E1"/>
+            <a:srgbClr val="F3F5F4"/>
           </a:solidFill>
           <a:ln>
             <a:noFill/>
@@ -16157,11 +16227,11 @@
             <a:r>
               <a:rPr sz="1300" b="1" i="0">
                 <a:solidFill>
-                  <a:srgbClr val="8A5300"/>
+                  <a:srgbClr val="14201F"/>
                 </a:solidFill>
                 <a:latin typeface="Arial"/>
               </a:rPr>
-              <a:t>Transfer</a:t>
+              <a:t>Sealed</a:t>
             </a:r>
           </a:p>
         </p:txBody>
@@ -16196,7 +16266,7 @@
                 </a:solidFill>
                 <a:latin typeface="Arial"/>
               </a:rPr>
-              <a:t>New payee, 30,000: the gateway asks for a STEP‑UP</a:t>
+              <a:t>Verdict and transfer decision hashed with model and policy</a:t>
             </a:r>
           </a:p>
         </p:txBody>
@@ -16319,7 +16389,7 @@
                 </a:solidFill>
                 <a:latin typeface="Arial"/>
               </a:rPr>
-              <a:t>Fresh proof</a:t>
+              <a:t>Verify</a:t>
             </a:r>
           </a:p>
         </p:txBody>
@@ -16354,7 +16424,7 @@
                 </a:solidFill>
                 <a:latin typeface="Arial"/>
               </a:rPr>
-              <a:t>One-time code verified before the transfer continues</a:t>
+              <a:t>Any change later fails against the contract</a:t>
             </a:r>
           </a:p>
         </p:txBody>
@@ -16477,7 +16547,7 @@
                 </a:solidFill>
                 <a:latin typeface="Arial"/>
               </a:rPr>
-              <a:t>Sealed</a:t>
+              <a:t>Report</a:t>
             </a:r>
           </a:p>
         </p:txBody>
@@ -16512,7 +16582,7 @@
                 </a:solidFill>
                 <a:latin typeface="Arial"/>
               </a:rPr>
-              <a:t>Plan, verdict and transfer each anchored and verifiable</a:t>
+              <a:t>Bank and regulator read every decision over OData</a:t>
             </a:r>
           </a:p>
         </p:txBody>
@@ -16547,7 +16617,7 @@
                 </a:solidFill>
                 <a:latin typeface="Arial"/>
               </a:rPr>
-              <a:t>Models score, rules decide: no model output reaches the user without passing a deterministic policy or the grounding check.</a:t>
+              <a:t>Today the transfer check and the message check run side by side; feeding the message verdict into the transfer decision is next.</a:t>
             </a:r>
           </a:p>
         </p:txBody>
@@ -18637,7 +18707,7 @@
                 </a:solidFill>
                 <a:latin typeface="Arial"/>
               </a:rPr>
-              <a:t>Policy P001, SHA-256 commitments, AuditRegistry.sol on an in-service EVM</a:t>
+              <a:t>Hash-committed decision log; AuditRegistry.sol on the audit service chain</a:t>
             </a:r>
           </a:p>
         </p:txBody>

</xml_diff>

<commit_message>
Deck and script: step-up is a pause, a question and a scam check
- Payment checkpoint described as it now works: the bank asks what the
  payment is for, runs Scam Shield on the answer, shows STOP before any code.
  Removes the contradiction with 'the victim passes the OTP herself'.
- Benchmark headline carries its caveat (synthetic set of 40, 45% -> 100%).
- CommBank 2026 figure for 'victims don't check'; gateway marked heuristic.
- USP: Sri Lanka first, APAC-ready (mostly data plus a policy version, no new
  services); next markets Singapore, Malaysia and India.
- Snapshots lead with the step-up STOP screen; cash planner screenshot dropped.
- Demo script's checkpoint scene rewritten for the integrated flow.
</commit_message>
<xml_diff>
--- a/docs/deck/FirstStep_AI_Builder_Cup_2026.pptx
+++ b/docs/deck/FirstStep_AI_Builder_Cup_2026.pptx
@@ -7357,7 +7357,7 @@
       </p:sp>
       <p:pic>
         <p:nvPicPr>
-          <p:cNvPr id="136" name="Picture 135" descr="shot-verdict.png"/>
+          <p:cNvPr id="136" name="Picture 135" descr="shot-stepup.png"/>
           <p:cNvPicPr>
             <a:picLocks noChangeAspect="1"/>
           </p:cNvPicPr>
@@ -7415,14 +7415,14 @@
                 </a:solidFill>
                 <a:latin typeface="Arial"/>
               </a:rPr>
-              <a:t>Scam Shield: STOP stamp, reasons, cited OKF scam patterns; red flags read by Gemini</a:t>
+              <a:t>Payment checkpoint: the bank asks what the payment is for and shows STOP before any code</a:t>
             </a:r>
           </a:p>
         </p:txBody>
       </p:sp>
       <p:pic>
         <p:nvPicPr>
-          <p:cNvPr id="138" name="Picture 137" descr="shot-assistant.png"/>
+          <p:cNvPr id="138" name="Picture 137" descr="shot-verdict.png"/>
           <p:cNvPicPr>
             <a:picLocks noChangeAspect="1"/>
           </p:cNvPicPr>
@@ -7480,14 +7480,14 @@
                 </a:solidFill>
                 <a:latin typeface="Arial"/>
               </a:rPr>
-              <a:t>Assistant answering in Sinhala, from the scam-check tool</a:t>
+              <a:t>Scam Shield: STOP stamp, reasons, cited OKF scam patterns; red flags read by Gemini</a:t>
             </a:r>
           </a:p>
         </p:txBody>
       </p:sp>
       <p:pic>
         <p:nvPicPr>
-          <p:cNvPr id="140" name="Picture 139" descr="shot-withdraw.png"/>
+          <p:cNvPr id="140" name="Picture 139" descr="shot-assistant.png"/>
           <p:cNvPicPr>
             <a:picLocks noChangeAspect="1"/>
           </p:cNvPicPr>
@@ -7545,7 +7545,7 @@
                 </a:solidFill>
                 <a:latin typeface="Arial"/>
               </a:rPr>
-              <a:t>Cash planner: feasible plan and its cost against three baselines</a:t>
+              <a:t>Assistant answering in Sinhala, from the scam-check tool</a:t>
             </a:r>
           </a:p>
         </p:txBody>
@@ -7836,13 +7836,13 @@
               </a:spcAft>
             </a:pPr>
             <a:r>
-              <a:rPr sz="1500" b="1" i="0">
+              <a:rPr sz="1300" b="1" i="0">
                 <a:solidFill>
                   <a:srgbClr val="0B6E4F"/>
                 </a:solidFill>
                 <a:latin typeface="Arial"/>
               </a:rPr>
-              <a:t>20 / 20 scams flagged, 0 false alarms</a:t>
+              <a:t>Synthetic test set (40 msgs): recall 45% → 100% with Gemini, 0 false positives</a:t>
             </a:r>
           </a:p>
           <a:p>
@@ -8890,7 +8890,7 @@
                 </a:solidFill>
                 <a:latin typeface="Arial"/>
               </a:rPr>
-              <a:t>Link the checks</a:t>
+              <a:t>Verdict into the score</a:t>
             </a:r>
           </a:p>
         </p:txBody>
@@ -8925,7 +8925,7 @@
                 </a:solidFill>
                 <a:latin typeface="Arial"/>
               </a:rPr>
-              <a:t>Feed the message verdict into the transfer decision.</a:t>
+              <a:t>Feed the scam verdict into the gateway's risk score, not only the step-up.</a:t>
             </a:r>
           </a:p>
         </p:txBody>
@@ -12044,7 +12044,7 @@
                 </a:solidFill>
                 <a:latin typeface="Arial"/>
               </a:rPr>
-              <a:t>Kamala starts a Rs 30,000 transfer; the gateway asks for fresh proof</a:t>
+              <a:t>Rs 30,000 to a new payee: before any code, the bank asks what it is for</a:t>
             </a:r>
           </a:p>
         </p:txBody>
@@ -12244,7 +12244,7 @@
                 </a:solidFill>
                 <a:latin typeface="Arial"/>
               </a:rPr>
-              <a:t>Check the offer</a:t>
+              <a:t>Scam check</a:t>
             </a:r>
           </a:p>
         </p:txBody>
@@ -12283,7 +12283,7 @@
                 </a:solidFill>
                 <a:latin typeface="Arial"/>
               </a:rPr>
-              <a:t>The WhatsApp message gets a STOP verdict, and why</a:t>
+              <a:t>She pastes the WhatsApp offer: STOP, and why, at the moment of payment</a:t>
             </a:r>
           </a:p>
         </p:txBody>
@@ -13087,11 +13087,11 @@
           <a:p>
             <a:pPr algn="l">
               <a:spcAft>
-                <a:spcPts val="700"/>
+                <a:spcPts val="500"/>
               </a:spcAft>
             </a:pPr>
             <a:r>
-              <a:rPr sz="1150" b="1" i="0">
+              <a:rPr sz="1050" b="1" i="0">
                 <a:solidFill>
                   <a:srgbClr val="0B6E4F"/>
                 </a:solidFill>
@@ -13100,23 +13100,23 @@
               <a:t>•  </a:t>
             </a:r>
             <a:r>
-              <a:rPr sz="1150" b="0" i="0">
+              <a:rPr sz="1050" b="0" i="0">
                 <a:solidFill>
                   <a:srgbClr val="14201F"/>
                 </a:solidFill>
                 <a:latin typeface="Arial"/>
               </a:rPr>
-              <a:t>Google Messages and ScamShield protect the phone and need the victim to doubt the offer; many victims never check</a:t>
+              <a:t>Google Messages and ScamShield protect the phone and need the victim to doubt the offer: 53% of victims aged 65+ who didn't check thought it unnecessary (CommBank, 2026)</a:t>
             </a:r>
           </a:p>
           <a:p>
             <a:pPr algn="l">
               <a:spcAft>
-                <a:spcPts val="700"/>
+                <a:spcPts val="500"/>
               </a:spcAft>
             </a:pPr>
             <a:r>
-              <a:rPr sz="1150" b="1" i="0">
+              <a:rPr sz="1050" b="1" i="0">
                 <a:solidFill>
                   <a:srgbClr val="0B6E4F"/>
                 </a:solidFill>
@@ -13125,7 +13125,7 @@
               <a:t>•  </a:t>
             </a:r>
             <a:r>
-              <a:rPr sz="1150" b="0" i="0">
+              <a:rPr sz="1050" b="0" i="0">
                 <a:solidFill>
                   <a:srgbClr val="14201F"/>
                 </a:solidFill>
@@ -13137,11 +13137,11 @@
           <a:p>
             <a:pPr algn="l">
               <a:spcAft>
-                <a:spcPts val="700"/>
+                <a:spcPts val="500"/>
               </a:spcAft>
             </a:pPr>
             <a:r>
-              <a:rPr sz="1150" b="1" i="0">
+              <a:rPr sz="1050" b="1" i="0">
                 <a:solidFill>
                   <a:srgbClr val="0B6E4F"/>
                 </a:solidFill>
@@ -13150,7 +13150,7 @@
               <a:t>•  </a:t>
             </a:r>
             <a:r>
-              <a:rPr sz="1150" b="0" i="0">
+              <a:rPr sz="1050" b="0" i="0">
                 <a:solidFill>
                   <a:srgbClr val="14201F"/>
                 </a:solidFill>
@@ -13264,11 +13264,11 @@
           <a:p>
             <a:pPr algn="l">
               <a:spcAft>
-                <a:spcPts val="700"/>
+                <a:spcPts val="500"/>
               </a:spcAft>
             </a:pPr>
             <a:r>
-              <a:rPr sz="1150" b="1" i="0">
+              <a:rPr sz="1050" b="1" i="0">
                 <a:solidFill>
                   <a:srgbClr val="0B6E4F"/>
                 </a:solidFill>
@@ -13277,23 +13277,23 @@
               <a:t>•  </a:t>
             </a:r>
             <a:r>
-              <a:rPr sz="1150" b="0" i="0">
+              <a:rPr sz="1050" b="0" i="0">
                 <a:solidFill>
                   <a:srgbClr val="14201F"/>
                 </a:solidFill>
                 <a:latin typeface="Arial"/>
               </a:rPr>
-              <a:t>Step-up on a new payee, the moment regulators single out as high risk</a:t>
+              <a:t>At a new payee the bank pauses and asks what the payment is for, the moment regulators single out as high risk</a:t>
             </a:r>
           </a:p>
           <a:p>
             <a:pPr algn="l">
               <a:spcAft>
-                <a:spcPts val="700"/>
+                <a:spcPts val="500"/>
               </a:spcAft>
             </a:pPr>
             <a:r>
-              <a:rPr sz="1150" b="1" i="0">
+              <a:rPr sz="1050" b="1" i="0">
                 <a:solidFill>
                   <a:srgbClr val="0B6E4F"/>
                 </a:solidFill>
@@ -13302,7 +13302,7 @@
               <a:t>•  </a:t>
             </a:r>
             <a:r>
-              <a:rPr sz="1150" b="0" i="0">
+              <a:rPr sz="1050" b="0" i="0">
                 <a:solidFill>
                   <a:srgbClr val="14201F"/>
                 </a:solidFill>
@@ -13314,11 +13314,11 @@
           <a:p>
             <a:pPr algn="l">
               <a:spcAft>
-                <a:spcPts val="700"/>
+                <a:spcPts val="500"/>
               </a:spcAft>
             </a:pPr>
             <a:r>
-              <a:rPr sz="1150" b="1" i="0">
+              <a:rPr sz="1050" b="1" i="0">
                 <a:solidFill>
                   <a:srgbClr val="0B6E4F"/>
                 </a:solidFill>
@@ -13327,7 +13327,7 @@
               <a:t>•  </a:t>
             </a:r>
             <a:r>
-              <a:rPr sz="1150" b="0" i="0">
+              <a:rPr sz="1050" b="0" i="0">
                 <a:solidFill>
                   <a:srgbClr val="14201F"/>
                 </a:solidFill>
@@ -13339,11 +13339,11 @@
           <a:p>
             <a:pPr algn="l">
               <a:spcAft>
-                <a:spcPts val="700"/>
+                <a:spcPts val="500"/>
               </a:spcAft>
             </a:pPr>
             <a:r>
-              <a:rPr sz="1150" b="1" i="0">
+              <a:rPr sz="1050" b="1" i="0">
                 <a:solidFill>
                   <a:srgbClr val="0B6E4F"/>
                 </a:solidFill>
@@ -13352,7 +13352,7 @@
               <a:t>•  </a:t>
             </a:r>
             <a:r>
-              <a:rPr sz="1150" b="0" i="0">
+              <a:rPr sz="1050" b="0" i="0">
                 <a:solidFill>
                   <a:srgbClr val="14201F"/>
                 </a:solidFill>
@@ -13466,11 +13466,11 @@
           <a:p>
             <a:pPr algn="l">
               <a:spcAft>
-                <a:spcPts val="700"/>
+                <a:spcPts val="500"/>
               </a:spcAft>
             </a:pPr>
             <a:r>
-              <a:rPr sz="1150" b="1" i="0">
+              <a:rPr sz="1050" b="1" i="0">
                 <a:solidFill>
                   <a:srgbClr val="0B6E4F"/>
                 </a:solidFill>
@@ -13479,7 +13479,7 @@
               <a:t>•  </a:t>
             </a:r>
             <a:r>
-              <a:rPr sz="1150" b="0" i="0">
+              <a:rPr sz="1050" b="0" i="0">
                 <a:solidFill>
                   <a:srgbClr val="14201F"/>
                 </a:solidFill>
@@ -13491,11 +13491,11 @@
           <a:p>
             <a:pPr algn="l">
               <a:spcAft>
-                <a:spcPts val="700"/>
+                <a:spcPts val="500"/>
               </a:spcAft>
             </a:pPr>
             <a:r>
-              <a:rPr sz="1150" b="1" i="0">
+              <a:rPr sz="1050" b="1" i="0">
                 <a:solidFill>
                   <a:srgbClr val="0B6E4F"/>
                 </a:solidFill>
@@ -13504,23 +13504,23 @@
               <a:t>•  </a:t>
             </a:r>
             <a:r>
-              <a:rPr sz="1150" b="0" i="0">
+              <a:rPr sz="1050" b="0" i="0">
                 <a:solidFill>
                   <a:srgbClr val="14201F"/>
                 </a:solidFill>
                 <a:latin typeface="Arial"/>
               </a:rPr>
-              <a:t>Live and tested on Cloud Run, not a slide: 11/11 end-to-end checks</a:t>
+              <a:t>Live and tested on Cloud Run: 11/11 end-to-end checks</a:t>
             </a:r>
           </a:p>
           <a:p>
             <a:pPr algn="l">
               <a:spcAft>
-                <a:spcPts val="700"/>
+                <a:spcPts val="500"/>
               </a:spcAft>
             </a:pPr>
             <a:r>
-              <a:rPr sz="1150" b="1" i="0">
+              <a:rPr sz="1050" b="1" i="0">
                 <a:solidFill>
                   <a:srgbClr val="0B6E4F"/>
                 </a:solidFill>
@@ -13529,13 +13529,38 @@
               <a:t>•  </a:t>
             </a:r>
             <a:r>
-              <a:rPr sz="1150" b="0" i="0">
+              <a:rPr sz="1050" b="0" i="0">
                 <a:solidFill>
                   <a:srgbClr val="14201F"/>
                 </a:solidFill>
                 <a:latin typeface="Arial"/>
               </a:rPr>
-              <a:t>Built for Sri Lanka: Sinhala, Tamil, LKR, CSE</a:t>
+              <a:t>Built for Sri Lanka first, APAC-ready: Sinhala, Tamil, LKR and CSE today; a new market is mostly data (regulator register, scam corpus, OKF pattern pack, Gemini language) plus a new policy version, no new services</a:t>
+            </a:r>
+          </a:p>
+          <a:p>
+            <a:pPr algn="l">
+              <a:spcAft>
+                <a:spcPts val="500"/>
+              </a:spcAft>
+            </a:pPr>
+            <a:r>
+              <a:rPr sz="1050" b="1" i="0">
+                <a:solidFill>
+                  <a:srgbClr val="0B6E4F"/>
+                </a:solidFill>
+                <a:latin typeface="Arial"/>
+              </a:rPr>
+              <a:t>•  </a:t>
+            </a:r>
+            <a:r>
+              <a:rPr sz="1050" b="0" i="0">
+                <a:solidFill>
+                  <a:srgbClr val="14201F"/>
+                </a:solidFill>
+                <a:latin typeface="Arial"/>
+              </a:rPr>
+              <a:t>Next markets: Singapore (bank duties under the Shared Responsibility Framework); Malaysia and India (Tamil already supported)</a:t>
             </a:r>
           </a:p>
         </p:txBody>
@@ -13905,7 +13930,7 @@
                 </a:solidFill>
                 <a:latin typeface="Arial"/>
               </a:rPr>
-              <a:t>Every transfer is scored by the gateway; a new payee or unusual behaviour triggers a one-time-code step-up before money leaves.</a:t>
+              <a:t>A new payee or unusual behaviour pauses the transfer: the bank asks what it is for, checks the answer with Scam Shield, and only then sends a one-time code.</a:t>
             </a:r>
           </a:p>
         </p:txBody>
@@ -15327,7 +15352,7 @@
                 </a:solidFill>
                 <a:latin typeface="Arial"/>
               </a:rPr>
-              <a:t>Behavioural and network risk score</a:t>
+              <a:t>Behavioural and payee-network risk score (heuristic)</a:t>
             </a:r>
           </a:p>
         </p:txBody>
@@ -15450,7 +15475,7 @@
                 </a:solidFill>
                 <a:latin typeface="Arial"/>
               </a:rPr>
-              <a:t>STEP‑UP</a:t>
+              <a:t>Pause &amp; ask</a:t>
             </a:r>
           </a:p>
         </p:txBody>
@@ -15485,7 +15510,7 @@
                 </a:solidFill>
                 <a:latin typeface="Arial"/>
               </a:rPr>
-              <a:t>Fresh one-time-code proof before money moves</a:t>
+              <a:t>“What is this payment for?” She pastes the WhatsApp offer</a:t>
             </a:r>
           </a:p>
         </p:txBody>
@@ -15608,7 +15633,7 @@
                 </a:solidFill>
                 <a:latin typeface="Arial"/>
               </a:rPr>
-              <a:t>Check the offer</a:t>
+              <a:t>Scam check</a:t>
             </a:r>
           </a:p>
         </p:txBody>
@@ -15643,7 +15668,7 @@
                 </a:solidFill>
                 <a:latin typeface="Arial"/>
               </a:rPr>
-              <a:t>Gemini reads the WhatsApp message's red flags</a:t>
+              <a:t>Gemini reads the red flags; SHIELD-P001 decides</a:t>
             </a:r>
           </a:p>
         </p:txBody>
@@ -15801,7 +15826,7 @@
                 </a:solidFill>
                 <a:latin typeface="Arial"/>
               </a:rPr>
-              <a:t>SHIELD-P001 verdict, what to do, why, scam patterns</a:t>
+              <a:t>Cancel is the default; continuing needs consent, then the code</a:t>
             </a:r>
           </a:p>
         </p:txBody>
@@ -16108,7 +16133,7 @@
                 </a:solidFill>
                 <a:latin typeface="Arial"/>
               </a:rPr>
-              <a:t>She cancels, or proves it is really her</a:t>
+              <a:t>She cancels, or acknowledges the risk and confirms with a code</a:t>
             </a:r>
           </a:p>
         </p:txBody>
@@ -16617,7 +16642,7 @@
                 </a:solidFill>
                 <a:latin typeface="Arial"/>
               </a:rPr>
-              <a:t>Today the transfer check and the message check run side by side; feeding the message verdict into the transfer decision is next.</a:t>
+              <a:t>The step-up runs Scam Shield on the customer's answer before any code is sent; feeding the verdict into the gateway's risk score is next.</a:t>
             </a:r>
           </a:p>
         </p:txBody>

</xml_diff>

<commit_message>
Deck: Try-it steps follow the live step-up flow
Transfer first: tick New beneficiary, 30,000, Score, answer 'what is it for?'
by pasting an offer, STOP, then cancel or acknowledge and enter the code, with
a hint for when repeated test transfers drift to BLOCK. Verified on the live
site end to end (cancel path and acknowledge-then-code path).
</commit_message>
<xml_diff>
--- a/docs/deck/FirstStep_AI_Builder_Cup_2026.pptx
+++ b/docs/deck/FirstStep_AI_Builder_Cup_2026.pptx
@@ -9824,7 +9824,7 @@
                 </a:solidFill>
                 <a:latin typeface="Arial"/>
               </a:rPr>
-              <a:t>Fraud → Scam Shield: paste an investment offer and see the verdict, reasons and scam patterns.</a:t>
+              <a:t>Fraud → Check a transfer: tick New beneficiary, amount 30,000 → Score → answer “what is it for?” by pasting an offer → STOP → cancel, or tick the warning and enter the code. (If it says BLOCK, type a new name in User.)</a:t>
             </a:r>
           </a:p>
           <a:p>
@@ -9840,7 +9840,7 @@
                 </a:solidFill>
                 <a:latin typeface="Arial"/>
               </a:rPr>
-              <a:t>Fraud → Check a transfer: tick New beneficiary, amount 30,000 → STEP-UP → enter the code.</a:t>
+              <a:t>Fraud → Scam Shield: paste any offer on its own and see the same verdict, reasons and scam patterns.</a:t>
             </a:r>
           </a:p>
           <a:p>

</xml_diff>

<commit_message>
Deck and README: add the demo video link
</commit_message>
<xml_diff>
--- a/docs/deck/FirstStep_AI_Builder_Cup_2026.pptx
+++ b/docs/deck/FirstStep_AI_Builder_Cup_2026.pptx
@@ -9641,11 +9641,12 @@
             <a:r>
               <a:rPr sz="1200">
                 <a:solidFill>
-                  <a:srgbClr val="B42318"/>
+                  <a:srgbClr val="0B6E4F"/>
                 </a:solidFill>
                 <a:latin typeface="Arial"/>
-              </a:rPr>
-              <a:t>ADD THE VIDEO LINK</a:t>
+                <a:hlinkClick r:id="rId6"/>
+              </a:rPr>
+              <a:t>https://youtu.be/LlTCFkWH23E</a:t>
             </a:r>
             <a:endParaRPr>
               <a:latin typeface="Google Sans Flex Medium"/>
@@ -9681,7 +9682,7 @@
                   <a:srgbClr val="0B6E4F"/>
                 </a:solidFill>
                 <a:latin typeface="Arial"/>
-                <a:hlinkClick r:id="rId6"/>
+                <a:hlinkClick r:id="rId7"/>
               </a:rPr>
               <a:t>https://firststep-web-214625202650.us-central1.run.app</a:t>
             </a:r>

</xml_diff>